<commit_message>
EEH投稿書類一式: manuscript.docx, cover_letter.docx, figures_pptx.pptx 再生成
- manuscript.docx: Harvard引用形式、図表インライン、本文約7,000語
- cover_letter.docx: EEH宛カバーレター（語数修正）
- figures_pptx.pptx: 編集可能な図版（1スライド/1図）
- 生成スクリプト追加（generate_docx.py等）

Co-Authored-By: Tatsuki Onishi <bougtoir@gmail.com>
</commit_message>
<xml_diff>
--- a/manuscript/figures_pptx.pptx
+++ b/manuscript/figures_pptx.pptx
@@ -3113,11 +3113,11 @@
           </a:bodyPr>
           <a:lstStyle/>
           <a:p>
-            <a:pPr>
+            <a:pPr algn="ctr">
               <a:defRPr sz="2400" b="1"/>
             </a:pPr>
             <a:r>
-              <a:t>Fig1</a:t>
+              <a:t>Fig. 1</a:t>
             </a:r>
           </a:p>
         </p:txBody>
@@ -3138,8 +3138,8 @@
         </p:blipFill>
         <p:spPr>
           <a:xfrm>
-            <a:off x="457200" y="914400"/>
-            <a:ext cx="10972800" cy="4572000"/>
+            <a:off x="1523847" y="914400"/>
+            <a:ext cx="9144000" cy="3803597"/>
           </a:xfrm>
           <a:prstGeom prst="rect">
             <a:avLst/>
@@ -3154,8 +3154,8 @@
         </p:nvSpPr>
         <p:spPr>
           <a:xfrm>
-            <a:off x="457200" y="5669280"/>
-            <a:ext cx="10972800" cy="914400"/>
+            <a:off x="457200" y="5760720"/>
+            <a:ext cx="11247120" cy="914400"/>
           </a:xfrm>
           <a:prstGeom prst="rect">
             <a:avLst/>
@@ -3168,11 +3168,11 @@
           </a:bodyPr>
           <a:lstStyle/>
           <a:p>
-            <a:pPr>
-              <a:defRPr sz="1200"/>
+            <a:pPr algn="l">
+              <a:defRPr sz="1100"/>
             </a:pPr>
             <a:r>
-              <a:t>Fig. 1  Conquest rates comparing network closure vs. open polities across three reclassification scenarios.</a:t>
+              <a:t>Conquest rates by closure classification across six sensitivity scenarios. Bars show conquest rates for closed (including technically excluded) vs. open polities. Significance thresholds: *p &lt; 0.05, **p &lt; 0.01.</a:t>
             </a:r>
           </a:p>
         </p:txBody>
@@ -3217,11 +3217,11 @@
           </a:bodyPr>
           <a:lstStyle/>
           <a:p>
-            <a:pPr>
+            <a:pPr algn="ctr">
               <a:defRPr sz="2400" b="1"/>
             </a:pPr>
             <a:r>
-              <a:t>Fig2</a:t>
+              <a:t>Fig. 2</a:t>
             </a:r>
           </a:p>
         </p:txBody>
@@ -3242,8 +3242,8 @@
         </p:blipFill>
         <p:spPr>
           <a:xfrm>
-            <a:off x="457200" y="914400"/>
-            <a:ext cx="10972800" cy="4572000"/>
+            <a:off x="2407747" y="914400"/>
+            <a:ext cx="7376201" cy="4572000"/>
           </a:xfrm>
           <a:prstGeom prst="rect">
             <a:avLst/>
@@ -3258,8 +3258,8 @@
         </p:nvSpPr>
         <p:spPr>
           <a:xfrm>
-            <a:off x="457200" y="5669280"/>
-            <a:ext cx="10972800" cy="914400"/>
+            <a:off x="457200" y="5760720"/>
+            <a:ext cx="11247120" cy="914400"/>
           </a:xfrm>
           <a:prstGeom prst="rect">
             <a:avLst/>
@@ -3272,11 +3272,11 @@
           </a:bodyPr>
           <a:lstStyle/>
           <a:p>
-            <a:pPr>
-              <a:defRPr sz="1200"/>
+            <a:pPr algn="l">
+              <a:defRPr sz="1100"/>
             </a:pPr>
             <a:r>
-              <a:t>Fig. 2  Fisher's exact test p-values for network closure → conquest association, showing transition to significance with reclassification.</a:t>
+              <a:t>Progressive strengthening of Fisher's exact test p-values as technically excluded polities are reclassified from open to closed. The dashed line indicates p = 0.05.</a:t>
             </a:r>
           </a:p>
         </p:txBody>
@@ -3321,11 +3321,11 @@
           </a:bodyPr>
           <a:lstStyle/>
           <a:p>
-            <a:pPr>
+            <a:pPr algn="ctr">
               <a:defRPr sz="2400" b="1"/>
             </a:pPr>
             <a:r>
-              <a:t>Fig3</a:t>
+              <a:t>Fig. 3</a:t>
             </a:r>
           </a:p>
         </p:txBody>
@@ -3346,8 +3346,8 @@
         </p:blipFill>
         <p:spPr>
           <a:xfrm>
-            <a:off x="457200" y="914400"/>
-            <a:ext cx="10972800" cy="4572000"/>
+            <a:off x="1523847" y="914400"/>
+            <a:ext cx="9144000" cy="3804662"/>
           </a:xfrm>
           <a:prstGeom prst="rect">
             <a:avLst/>
@@ -3362,8 +3362,8 @@
         </p:nvSpPr>
         <p:spPr>
           <a:xfrm>
-            <a:off x="457200" y="5669280"/>
-            <a:ext cx="10972800" cy="914400"/>
+            <a:off x="457200" y="5760720"/>
+            <a:ext cx="11247120" cy="914400"/>
           </a:xfrm>
           <a:prstGeom prst="rect">
             <a:avLst/>
@@ -3376,11 +3376,11 @@
           </a:bodyPr>
           <a:lstStyle/>
           <a:p>
-            <a:pPr>
-              <a:defRPr sz="1200"/>
+            <a:pPr algn="l">
+              <a:defRPr sz="1100"/>
             </a:pPr>
             <a:r>
-              <a:t>Fig. 3  Conquest rates by closure type under the 7-country reclassification scenario.</a:t>
+              <a:t>Conquest rates disaggregated by closure type under the 7-country reclassification. Technical exclusion (zero technology flow) produces the highest conquest rate, followed by policy bans, sakoku, and bloc closures.</a:t>
             </a:r>
           </a:p>
         </p:txBody>
@@ -3425,11 +3425,11 @@
           </a:bodyPr>
           <a:lstStyle/>
           <a:p>
-            <a:pPr>
+            <a:pPr algn="ctr">
               <a:defRPr sz="2400" b="1"/>
             </a:pPr>
             <a:r>
-              <a:t>Fig4</a:t>
+              <a:t>Fig. 4</a:t>
             </a:r>
           </a:p>
         </p:txBody>
@@ -3450,8 +3450,8 @@
         </p:blipFill>
         <p:spPr>
           <a:xfrm>
-            <a:off x="457200" y="914400"/>
-            <a:ext cx="10972800" cy="4572000"/>
+            <a:off x="3033202" y="914400"/>
+            <a:ext cx="6125291" cy="4572000"/>
           </a:xfrm>
           <a:prstGeom prst="rect">
             <a:avLst/>
@@ -3466,8 +3466,8 @@
         </p:nvSpPr>
         <p:spPr>
           <a:xfrm>
-            <a:off x="457200" y="5669280"/>
-            <a:ext cx="10972800" cy="914400"/>
+            <a:off x="457200" y="5760720"/>
+            <a:ext cx="11247120" cy="914400"/>
           </a:xfrm>
           <a:prstGeom prst="rect">
             <a:avLst/>
@@ -3480,11 +3480,11 @@
           </a:bodyPr>
           <a:lstStyle/>
           <a:p>
-            <a:pPr>
-              <a:defRPr sz="1200"/>
+            <a:pPr algn="l">
+              <a:defRPr sz="1100"/>
             </a:pPr>
             <a:r>
-              <a:t>Fig. 4  Forest plot of multivariate logistic regression odds ratios (7-country reclassification, disrupted→overtaken).</a:t>
+              <a:t>Forest plot of multivariate logistic regression coefficients (log-odds) under the 7-country reclassification with disrupted = overtaken. External threat and institutional quality are the strongest predictors; the network closure indicator is not independently significant.</a:t>
             </a:r>
           </a:p>
         </p:txBody>

</xml_diff>

<commit_message>
Add provenance audit and reproducible national-power dataset
Co-Authored-By: Tatsuki Onishi <bougtoir@gmail.com>
</commit_message>
<xml_diff>
--- a/manuscript/figures_pptx.pptx
+++ b/manuscript/figures_pptx.pptx
@@ -3113,11 +3113,11 @@
           </a:bodyPr>
           <a:lstStyle/>
           <a:p>
-            <a:pPr algn="ctr">
+            <a:pPr>
               <a:defRPr sz="2400" b="1"/>
             </a:pPr>
             <a:r>
-              <a:t>Fig. 1</a:t>
+              <a:t>Fig1</a:t>
             </a:r>
           </a:p>
         </p:txBody>
@@ -3138,8 +3138,8 @@
         </p:blipFill>
         <p:spPr>
           <a:xfrm>
-            <a:off x="1523847" y="914400"/>
-            <a:ext cx="9144000" cy="3803597"/>
+            <a:off x="457200" y="914400"/>
+            <a:ext cx="10972800" cy="4572000"/>
           </a:xfrm>
           <a:prstGeom prst="rect">
             <a:avLst/>
@@ -3154,8 +3154,8 @@
         </p:nvSpPr>
         <p:spPr>
           <a:xfrm>
-            <a:off x="457200" y="5760720"/>
-            <a:ext cx="11247120" cy="914400"/>
+            <a:off x="457200" y="5669280"/>
+            <a:ext cx="10972800" cy="914400"/>
           </a:xfrm>
           <a:prstGeom prst="rect">
             <a:avLst/>
@@ -3168,11 +3168,11 @@
           </a:bodyPr>
           <a:lstStyle/>
           <a:p>
-            <a:pPr algn="l">
-              <a:defRPr sz="1100"/>
+            <a:pPr>
+              <a:defRPr sz="1200"/>
             </a:pPr>
             <a:r>
-              <a:t>Conquest rates by closure classification across six sensitivity scenarios. Bars show conquest rates for closed (including technically excluded) vs. open polities. Significance thresholds: *p &lt; 0.05, **p &lt; 0.01.</a:t>
+              <a:t>Fig. 1  Conquest rates comparing network closure vs. open polities across three reclassification scenarios.</a:t>
             </a:r>
           </a:p>
         </p:txBody>
@@ -3217,11 +3217,11 @@
           </a:bodyPr>
           <a:lstStyle/>
           <a:p>
-            <a:pPr algn="ctr">
+            <a:pPr>
               <a:defRPr sz="2400" b="1"/>
             </a:pPr>
             <a:r>
-              <a:t>Fig. 2</a:t>
+              <a:t>Fig2</a:t>
             </a:r>
           </a:p>
         </p:txBody>
@@ -3242,8 +3242,8 @@
         </p:blipFill>
         <p:spPr>
           <a:xfrm>
-            <a:off x="2407747" y="914400"/>
-            <a:ext cx="7376201" cy="4572000"/>
+            <a:off x="457200" y="914400"/>
+            <a:ext cx="10972800" cy="4572000"/>
           </a:xfrm>
           <a:prstGeom prst="rect">
             <a:avLst/>
@@ -3258,8 +3258,8 @@
         </p:nvSpPr>
         <p:spPr>
           <a:xfrm>
-            <a:off x="457200" y="5760720"/>
-            <a:ext cx="11247120" cy="914400"/>
+            <a:off x="457200" y="5669280"/>
+            <a:ext cx="10972800" cy="914400"/>
           </a:xfrm>
           <a:prstGeom prst="rect">
             <a:avLst/>
@@ -3272,11 +3272,11 @@
           </a:bodyPr>
           <a:lstStyle/>
           <a:p>
-            <a:pPr algn="l">
-              <a:defRPr sz="1100"/>
+            <a:pPr>
+              <a:defRPr sz="1200"/>
             </a:pPr>
             <a:r>
-              <a:t>Progressive strengthening of Fisher's exact test p-values as technically excluded polities are reclassified from open to closed. The dashed line indicates p = 0.05.</a:t>
+              <a:t>Fig. 2  Sensitivity of Fisher exact p-values for closure and conquest to reclassification.</a:t>
             </a:r>
           </a:p>
         </p:txBody>
@@ -3321,11 +3321,11 @@
           </a:bodyPr>
           <a:lstStyle/>
           <a:p>
-            <a:pPr algn="ctr">
+            <a:pPr>
               <a:defRPr sz="2400" b="1"/>
             </a:pPr>
             <a:r>
-              <a:t>Fig. 3</a:t>
+              <a:t>Fig3</a:t>
             </a:r>
           </a:p>
         </p:txBody>
@@ -3346,8 +3346,8 @@
         </p:blipFill>
         <p:spPr>
           <a:xfrm>
-            <a:off x="1523847" y="914400"/>
-            <a:ext cx="9144000" cy="3804662"/>
+            <a:off x="457200" y="914400"/>
+            <a:ext cx="10972800" cy="4572000"/>
           </a:xfrm>
           <a:prstGeom prst="rect">
             <a:avLst/>
@@ -3362,8 +3362,8 @@
         </p:nvSpPr>
         <p:spPr>
           <a:xfrm>
-            <a:off x="457200" y="5760720"/>
-            <a:ext cx="11247120" cy="914400"/>
+            <a:off x="457200" y="5669280"/>
+            <a:ext cx="10972800" cy="914400"/>
           </a:xfrm>
           <a:prstGeom prst="rect">
             <a:avLst/>
@@ -3376,11 +3376,11 @@
           </a:bodyPr>
           <a:lstStyle/>
           <a:p>
-            <a:pPr algn="l">
-              <a:defRPr sz="1100"/>
+            <a:pPr>
+              <a:defRPr sz="1200"/>
             </a:pPr>
             <a:r>
-              <a:t>Conquest rates disaggregated by closure type under the 7-country reclassification. Technical exclusion (zero technology flow) produces the highest conquest rate, followed by policy bans, sakoku, and bloc closures.</a:t>
+              <a:t>Fig. 3  Conquest rates by closure type under the 7-country reclassification scenario.</a:t>
             </a:r>
           </a:p>
         </p:txBody>
@@ -3425,11 +3425,11 @@
           </a:bodyPr>
           <a:lstStyle/>
           <a:p>
-            <a:pPr algn="ctr">
+            <a:pPr>
               <a:defRPr sz="2400" b="1"/>
             </a:pPr>
             <a:r>
-              <a:t>Fig. 4</a:t>
+              <a:t>Fig4</a:t>
             </a:r>
           </a:p>
         </p:txBody>
@@ -3450,8 +3450,8 @@
         </p:blipFill>
         <p:spPr>
           <a:xfrm>
-            <a:off x="3033202" y="914400"/>
-            <a:ext cx="6125291" cy="4572000"/>
+            <a:off x="457200" y="914400"/>
+            <a:ext cx="10972800" cy="4572000"/>
           </a:xfrm>
           <a:prstGeom prst="rect">
             <a:avLst/>
@@ -3466,8 +3466,8 @@
         </p:nvSpPr>
         <p:spPr>
           <a:xfrm>
-            <a:off x="457200" y="5760720"/>
-            <a:ext cx="11247120" cy="914400"/>
+            <a:off x="457200" y="5669280"/>
+            <a:ext cx="10972800" cy="914400"/>
           </a:xfrm>
           <a:prstGeom prst="rect">
             <a:avLst/>
@@ -3480,11 +3480,11 @@
           </a:bodyPr>
           <a:lstStyle/>
           <a:p>
-            <a:pPr algn="l">
-              <a:defRPr sz="1100"/>
+            <a:pPr>
+              <a:defRPr sz="1200"/>
             </a:pPr>
             <a:r>
-              <a:t>Forest plot of multivariate logistic regression coefficients (log-odds) under the 7-country reclassification with disrupted = overtaken. External threat and institutional quality are the strongest predictors; the network closure indicator is not independently significant.</a:t>
+              <a:t>Fig. 4  Forest plot of multivariate logistic regression odds ratios (7-country reclassification, disrupted→overtaken).</a:t>
             </a:r>
           </a:p>
         </p:txBody>

</xml_diff>